<commit_message>
Personaliza repositório para a disciplina CloudTask AI SaaS
- README adaptado: descrição, stack, roadmap por aula, guia rápido de uso
- Banner atualizado (PNG/PPTX) com identidade da disciplina
- .gitignore reforçado: Docker, IDE, OS, uploads/eventos locais, segredos, CDK
- .env.example cobrindo todas as variáveis previstas (aulas 1–10)
- docs/ROADMAP.md detalhando 12 aulas, branches, tags e entregas
- docs/HOW_TO_USE.md com pré-requisitos, comandos e troubleshooting para alunos
</commit_message>
<xml_diff>
--- a/.readme_docs/Banner_Github_NCPU.pptx
+++ b/.readme_docs/Banner_Github_NCPU.pptx
@@ -115,7 +115,7 @@
 <file path=ppt/revisionInfo.xml><?xml version="1.0" encoding="utf-8"?>
 <p1510:revInfo xmlns:a="http://schemas.openxmlformats.org/drawingml/2006/main" xmlns:r="http://schemas.openxmlformats.org/officeDocument/2006/relationships" xmlns:p1510="http://schemas.microsoft.com/office/powerpoint/2015/10/main">
   <p1510:revLst>
-    <p1510:client id="{05905FDB-D48F-4E79-AA8A-F5808E2D8858}" v="1" dt="2023-08-11T22:06:37.543"/>
+    <p1510:client id="{6E31517A-BF1F-424F-BC3A-2D03C8526EF6}" v="2" dt="2026-05-26T20:13:39.297"/>
   </p1510:revLst>
 </p1510:revInfo>
 </file>
@@ -123,20 +123,20 @@
 <file path=ppt/changesInfos/changesInfo1.xml><?xml version="1.0" encoding="utf-8"?>
 <pc:chgInfo xmlns:a="http://schemas.openxmlformats.org/drawingml/2006/main" xmlns:r="http://schemas.openxmlformats.org/officeDocument/2006/relationships" xmlns:ac="http://schemas.microsoft.com/office/drawing/2013/main/command" xmlns:pc="http://schemas.microsoft.com/office/powerpoint/2013/main/command">
   <pc:docChgLst>
-    <pc:chgData name="Guilherme Patriota" userId="72905d894d010fb5" providerId="LiveId" clId="{05905FDB-D48F-4E79-AA8A-F5808E2D8858}"/>
-    <pc:docChg chg="custSel modSld">
-      <pc:chgData name="Guilherme Patriota" userId="72905d894d010fb5" providerId="LiveId" clId="{05905FDB-D48F-4E79-AA8A-F5808E2D8858}" dt="2023-08-11T22:07:48.047" v="85" actId="20577"/>
+    <pc:chgData name="Guilherme Ditzel Patriota" userId="72905d894d010fb5" providerId="LiveId" clId="{11FCD27B-4CE6-4C4F-8910-5BFBB0654483}"/>
+    <pc:docChg chg="undo custSel modSld">
+      <pc:chgData name="Guilherme Ditzel Patriota" userId="72905d894d010fb5" providerId="LiveId" clId="{11FCD27B-4CE6-4C4F-8910-5BFBB0654483}" dt="2026-05-26T20:13:50.125" v="23" actId="20577"/>
       <pc:docMkLst>
         <pc:docMk/>
       </pc:docMkLst>
-      <pc:sldChg chg="addSp modSp mod">
-        <pc:chgData name="Guilherme Patriota" userId="72905d894d010fb5" providerId="LiveId" clId="{05905FDB-D48F-4E79-AA8A-F5808E2D8858}" dt="2023-08-11T22:07:48.047" v="85" actId="20577"/>
+      <pc:sldChg chg="modSp mod">
+        <pc:chgData name="Guilherme Ditzel Patriota" userId="72905d894d010fb5" providerId="LiveId" clId="{11FCD27B-4CE6-4C4F-8910-5BFBB0654483}" dt="2026-05-26T20:13:50.125" v="23" actId="20577"/>
         <pc:sldMkLst>
           <pc:docMk/>
           <pc:sldMk cId="2012489269" sldId="256"/>
         </pc:sldMkLst>
-        <pc:spChg chg="add mod">
-          <ac:chgData name="Guilherme Patriota" userId="72905d894d010fb5" providerId="LiveId" clId="{05905FDB-D48F-4E79-AA8A-F5808E2D8858}" dt="2023-08-11T22:07:17.049" v="39" actId="20577"/>
+        <pc:spChg chg="mod">
+          <ac:chgData name="Guilherme Ditzel Patriota" userId="72905d894d010fb5" providerId="LiveId" clId="{11FCD27B-4CE6-4C4F-8910-5BFBB0654483}" dt="2026-05-26T20:13:50.125" v="23" actId="20577"/>
           <ac:spMkLst>
             <pc:docMk/>
             <pc:sldMk cId="2012489269" sldId="256"/>
@@ -144,31 +144,7 @@
           </ac:spMkLst>
         </pc:spChg>
         <pc:spChg chg="mod">
-          <ac:chgData name="Guilherme Patriota" userId="72905d894d010fb5" providerId="LiveId" clId="{05905FDB-D48F-4E79-AA8A-F5808E2D8858}" dt="2023-08-11T22:07:48.047" v="85" actId="20577"/>
-          <ac:spMkLst>
-            <pc:docMk/>
-            <pc:sldMk cId="2012489269" sldId="256"/>
-            <ac:spMk id="6" creationId="{0AF42E7D-7CE3-01CB-D42F-1B05CD74D183}"/>
-          </ac:spMkLst>
-        </pc:spChg>
-      </pc:sldChg>
-    </pc:docChg>
-  </pc:docChgLst>
-  <pc:docChgLst>
-    <pc:chgData name="Guilherme Patriota" userId="72905d894d010fb5" providerId="LiveId" clId="{1CE444F9-D2C4-46F4-B101-06F85C142A18}"/>
-    <pc:docChg chg="undo redo custSel modSld">
-      <pc:chgData name="Guilherme Patriota" userId="72905d894d010fb5" providerId="LiveId" clId="{1CE444F9-D2C4-46F4-B101-06F85C142A18}" dt="2023-06-30T23:50:28.254" v="82" actId="1076"/>
-      <pc:docMkLst>
-        <pc:docMk/>
-      </pc:docMkLst>
-      <pc:sldChg chg="modSp mod">
-        <pc:chgData name="Guilherme Patriota" userId="72905d894d010fb5" providerId="LiveId" clId="{1CE444F9-D2C4-46F4-B101-06F85C142A18}" dt="2023-06-30T23:50:28.254" v="82" actId="1076"/>
-        <pc:sldMkLst>
-          <pc:docMk/>
-          <pc:sldMk cId="2012489269" sldId="256"/>
-        </pc:sldMkLst>
-        <pc:spChg chg="mod">
-          <ac:chgData name="Guilherme Patriota" userId="72905d894d010fb5" providerId="LiveId" clId="{1CE444F9-D2C4-46F4-B101-06F85C142A18}" dt="2023-06-30T23:50:28.254" v="82" actId="1076"/>
+          <ac:chgData name="Guilherme Ditzel Patriota" userId="72905d894d010fb5" providerId="LiveId" clId="{11FCD27B-4CE6-4C4F-8910-5BFBB0654483}" dt="2026-05-26T20:13:42.252" v="4"/>
           <ac:spMkLst>
             <pc:docMk/>
             <pc:sldMk cId="2012489269" sldId="256"/>
@@ -312,7 +288,7 @@
           <a:p>
             <a:fld id="{F6929F03-BFF4-4D7F-B4B7-038F2A57863A}" type="datetimeFigureOut">
               <a:rPr lang="en-CA" smtClean="0"/>
-              <a:t>2023-08-11</a:t>
+              <a:t>2026-05-26</a:t>
             </a:fld>
             <a:endParaRPr lang="en-CA"/>
           </a:p>
@@ -482,7 +458,7 @@
           <a:p>
             <a:fld id="{F6929F03-BFF4-4D7F-B4B7-038F2A57863A}" type="datetimeFigureOut">
               <a:rPr lang="en-CA" smtClean="0"/>
-              <a:t>2023-08-11</a:t>
+              <a:t>2026-05-26</a:t>
             </a:fld>
             <a:endParaRPr lang="en-CA"/>
           </a:p>
@@ -662,7 +638,7 @@
           <a:p>
             <a:fld id="{F6929F03-BFF4-4D7F-B4B7-038F2A57863A}" type="datetimeFigureOut">
               <a:rPr lang="en-CA" smtClean="0"/>
-              <a:t>2023-08-11</a:t>
+              <a:t>2026-05-26</a:t>
             </a:fld>
             <a:endParaRPr lang="en-CA"/>
           </a:p>
@@ -832,7 +808,7 @@
           <a:p>
             <a:fld id="{F6929F03-BFF4-4D7F-B4B7-038F2A57863A}" type="datetimeFigureOut">
               <a:rPr lang="en-CA" smtClean="0"/>
-              <a:t>2023-08-11</a:t>
+              <a:t>2026-05-26</a:t>
             </a:fld>
             <a:endParaRPr lang="en-CA"/>
           </a:p>
@@ -1078,7 +1054,7 @@
           <a:p>
             <a:fld id="{F6929F03-BFF4-4D7F-B4B7-038F2A57863A}" type="datetimeFigureOut">
               <a:rPr lang="en-CA" smtClean="0"/>
-              <a:t>2023-08-11</a:t>
+              <a:t>2026-05-26</a:t>
             </a:fld>
             <a:endParaRPr lang="en-CA"/>
           </a:p>
@@ -1310,7 +1286,7 @@
           <a:p>
             <a:fld id="{F6929F03-BFF4-4D7F-B4B7-038F2A57863A}" type="datetimeFigureOut">
               <a:rPr lang="en-CA" smtClean="0"/>
-              <a:t>2023-08-11</a:t>
+              <a:t>2026-05-26</a:t>
             </a:fld>
             <a:endParaRPr lang="en-CA"/>
           </a:p>
@@ -1677,7 +1653,7 @@
           <a:p>
             <a:fld id="{F6929F03-BFF4-4D7F-B4B7-038F2A57863A}" type="datetimeFigureOut">
               <a:rPr lang="en-CA" smtClean="0"/>
-              <a:t>2023-08-11</a:t>
+              <a:t>2026-05-26</a:t>
             </a:fld>
             <a:endParaRPr lang="en-CA"/>
           </a:p>
@@ -1795,7 +1771,7 @@
           <a:p>
             <a:fld id="{F6929F03-BFF4-4D7F-B4B7-038F2A57863A}" type="datetimeFigureOut">
               <a:rPr lang="en-CA" smtClean="0"/>
-              <a:t>2023-08-11</a:t>
+              <a:t>2026-05-26</a:t>
             </a:fld>
             <a:endParaRPr lang="en-CA"/>
           </a:p>
@@ -1890,7 +1866,7 @@
           <a:p>
             <a:fld id="{F6929F03-BFF4-4D7F-B4B7-038F2A57863A}" type="datetimeFigureOut">
               <a:rPr lang="en-CA" smtClean="0"/>
-              <a:t>2023-08-11</a:t>
+              <a:t>2026-05-26</a:t>
             </a:fld>
             <a:endParaRPr lang="en-CA"/>
           </a:p>
@@ -2167,7 +2143,7 @@
           <a:p>
             <a:fld id="{F6929F03-BFF4-4D7F-B4B7-038F2A57863A}" type="datetimeFigureOut">
               <a:rPr lang="en-CA" smtClean="0"/>
-              <a:t>2023-08-11</a:t>
+              <a:t>2026-05-26</a:t>
             </a:fld>
             <a:endParaRPr lang="en-CA"/>
           </a:p>
@@ -2424,7 +2400,7 @@
           <a:p>
             <a:fld id="{F6929F03-BFF4-4D7F-B4B7-038F2A57863A}" type="datetimeFigureOut">
               <a:rPr lang="en-CA" smtClean="0"/>
-              <a:t>2023-08-11</a:t>
+              <a:t>2026-05-26</a:t>
             </a:fld>
             <a:endParaRPr lang="en-CA"/>
           </a:p>
@@ -2637,7 +2613,7 @@
           <a:p>
             <a:fld id="{F6929F03-BFF4-4D7F-B4B7-038F2A57863A}" type="datetimeFigureOut">
               <a:rPr lang="en-CA" smtClean="0"/>
-              <a:t>2023-08-11</a:t>
+              <a:t>2026-05-26</a:t>
             </a:fld>
             <a:endParaRPr lang="en-CA"/>
           </a:p>
@@ -3092,8 +3068,8 @@
         </p:nvSpPr>
         <p:spPr>
           <a:xfrm>
-            <a:off x="11516291" y="3294100"/>
-            <a:ext cx="18158304" cy="2215991"/>
+            <a:off x="14100908" y="3294100"/>
+            <a:ext cx="12989069" cy="2215991"/>
           </a:xfrm>
           <a:prstGeom prst="rect">
             <a:avLst/>
@@ -3117,6 +3093,26 @@
           <a:lstStyle/>
           <a:p>
             <a:pPr algn="ctr"/>
+            <a:r>
+              <a:rPr lang="pt-BR" sz="13800" dirty="0" err="1">
+                <a:ln>
+                  <a:solidFill>
+                    <a:srgbClr val="FFA716"/>
+                  </a:solidFill>
+                </a:ln>
+                <a:solidFill>
+                  <a:srgbClr val="FFA716"/>
+                </a:solidFill>
+                <a:effectLst>
+                  <a:outerShdw blurRad="60007" dist="310007" dir="7680000" sy="30000" kx="1300200" algn="ctr" rotWithShape="0">
+                    <a:prstClr val="black">
+                      <a:alpha val="32000"/>
+                    </a:prstClr>
+                  </a:outerShdw>
+                </a:effectLst>
+              </a:rPr>
+              <a:t>CloudTask</a:t>
+            </a:r>
             <a:r>
               <a:rPr lang="pt-BR" sz="13800" dirty="0">
                 <a:ln>
@@ -3135,7 +3131,7 @@
                   </a:outerShdw>
                 </a:effectLst>
               </a:rPr>
-              <a:t>TÍTULO DO REPOSITÓRIO</a:t>
+              <a:t> AI SaaS</a:t>
             </a:r>
           </a:p>
         </p:txBody>
@@ -3154,8 +3150,8 @@
         </p:nvSpPr>
         <p:spPr>
           <a:xfrm>
-            <a:off x="16112765" y="5532316"/>
-            <a:ext cx="8965339" cy="1569660"/>
+            <a:off x="14472802" y="5532316"/>
+            <a:ext cx="12245275" cy="1569660"/>
           </a:xfrm>
           <a:prstGeom prst="rect">
             <a:avLst/>
@@ -3197,7 +3193,7 @@
                   </a:outerShdw>
                 </a:effectLst>
               </a:rPr>
-              <a:t>Nome da Matéria</a:t>
+              <a:t>Computação em Nuvem</a:t>
             </a:r>
           </a:p>
         </p:txBody>

</xml_diff>